<commit_message>
add: readme and change presentation document
</commit_message>
<xml_diff>
--- a/VilleNova-Presentation.pptx
+++ b/VilleNova-Presentation.pptx
@@ -13,6 +13,9 @@
     <p:sldId id="258" r:id="rId4"/>
     <p:sldId id="259" r:id="rId5"/>
     <p:sldId id="260" r:id="rId6"/>
+    <p:sldId id="272" r:id="rId23"/>
+    <p:sldId id="270" r:id="rId21"/>
+    <p:sldId id="271" r:id="rId22"/>
     <p:sldId id="261" r:id="rId7"/>
     <p:sldId id="262" r:id="rId8"/>
     <p:sldId id="263" r:id="rId9"/>
@@ -1940,7 +1943,7 @@
                 <a:ea typeface="Calibri" pitchFamily="34" charset="-122"/>
                 <a:cs typeface="Calibri" pitchFamily="34" charset="-120"/>
               </a:rPr>
-              <a:t>Plateforme événementielle </a:t>
+              <a:t xml:space="preserve">Plateforme événementielle </a:t>
             </a:r>
             <a:r>
               <a:rPr lang="en-US" sz="1300" dirty="0" err="1">
@@ -1962,7 +1965,7 @@
                 <a:ea typeface="Calibri" pitchFamily="34" charset="-122"/>
                 <a:cs typeface="Calibri" pitchFamily="34" charset="-120"/>
               </a:rPr>
-              <a:t>  </a:t>
+              <a:t xml:space="preserve">  </a:t>
             </a:r>
             <a:endParaRPr lang="en-US" sz="1300" dirty="0"/>
           </a:p>
@@ -2001,7 +2004,7 @@
                 <a:ea typeface="Calibri" pitchFamily="34" charset="-122"/>
                 <a:cs typeface="Calibri" pitchFamily="34" charset="-120"/>
               </a:rPr>
-              <a:t>Samba Diop Gomis  —  Bachelor </a:t>
+              <a:t xml:space="preserve">Samba Diop Gomis  —  Bachelor </a:t>
             </a:r>
             <a:r>
               <a:rPr lang="en-US" sz="1300" dirty="0" err="1">
@@ -2023,7 +2026,7 @@
                 <a:ea typeface="Calibri" pitchFamily="34" charset="-122"/>
                 <a:cs typeface="Calibri" pitchFamily="34" charset="-120"/>
               </a:rPr>
-              <a:t> </a:t>
+              <a:t xml:space="preserve"> </a:t>
             </a:r>
             <a:r>
               <a:rPr lang="en-US" sz="1300" dirty="0" err="1">
@@ -2045,7 +2048,7 @@
                 <a:ea typeface="Calibri" pitchFamily="34" charset="-122"/>
                 <a:cs typeface="Calibri" pitchFamily="34" charset="-120"/>
               </a:rPr>
-              <a:t> – La </a:t>
+              <a:t xml:space="preserve"> – La </a:t>
             </a:r>
             <a:r>
               <a:rPr lang="en-US" sz="1300" dirty="0" err="1">
@@ -2892,7 +2895,7 @@
                 <a:ea typeface="Calibri" pitchFamily="34" charset="-122"/>
                 <a:cs typeface="Calibri" pitchFamily="34" charset="-120"/>
               </a:rPr>
-              <a:t>10 / 14</a:t>
+              <a:t>13 / 17</a:t>
             </a:r>
             <a:endParaRPr lang="en-US" sz="900" dirty="0"/>
           </a:p>
@@ -3454,7 +3457,7 @@
                 <a:ea typeface="Calibri" pitchFamily="34" charset="-122"/>
                 <a:cs typeface="Calibri" pitchFamily="34" charset="-120"/>
               </a:rPr>
-              <a:t>11 / 14</a:t>
+              <a:t>14 / 17</a:t>
             </a:r>
             <a:endParaRPr lang="en-US" sz="900" dirty="0"/>
           </a:p>
@@ -3938,7 +3941,7 @@
                 <a:ea typeface="Calibri" pitchFamily="34" charset="-122"/>
                 <a:cs typeface="Calibri" pitchFamily="34" charset="-120"/>
               </a:rPr>
-              <a:t>12 / 14</a:t>
+              <a:t>15 / 17</a:t>
             </a:r>
             <a:endParaRPr lang="en-US" sz="900" dirty="0"/>
           </a:p>
@@ -4906,7 +4909,7 @@
                 <a:ea typeface="Calibri" pitchFamily="34" charset="-122"/>
                 <a:cs typeface="Calibri" pitchFamily="34" charset="-120"/>
               </a:rPr>
-              <a:t>13 / 14</a:t>
+              <a:t>16 / 17</a:t>
             </a:r>
             <a:endParaRPr lang="en-US" sz="900" dirty="0"/>
           </a:p>
@@ -5101,7 +5104,7 @@
                 <a:ea typeface="Calibri" pitchFamily="34" charset="-122"/>
                 <a:cs typeface="Calibri" pitchFamily="34" charset="-120"/>
               </a:rPr>
-              <a:t>Samba Diop Gomis  ·  </a:t>
+              <a:t xml:space="preserve">Samba Diop Gomis  ·  </a:t>
             </a:r>
             <a:r>
               <a:rPr lang="en-US" sz="1300" dirty="0" err="1">
@@ -5123,7 +5126,7 @@
                 <a:ea typeface="Calibri" pitchFamily="34" charset="-122"/>
                 <a:cs typeface="Calibri" pitchFamily="34" charset="-120"/>
               </a:rPr>
-              <a:t> : samba-</a:t>
+              <a:t xml:space="preserve"> : samba-</a:t>
             </a:r>
             <a:r>
               <a:rPr lang="en-US" sz="1300" dirty="0" err="1">
@@ -5149,6 +5152,1145 @@
     <mc:Choice Requires="p15">
       <p:transition xmlns:p14="http://schemas.microsoft.com/office/powerpoint/2010/main" spd="slow" p14:dur="6000">
         <p15:prstTrans prst="curtains"/>
+      </p:transition>
+    </mc:Choice>
+    <mc:Fallback xmlns="">
+      <p:transition spd="slow">
+        <p:fade/>
+      </p:transition>
+    </mc:Fallback>
+  </mc:AlternateContent>
+</p:sld>
+</file>
+
+<file path=ppt/slides/slide15.xml><?xml version="1.0" encoding="utf-8"?>
+<p:sld xmlns:a="http://schemas.openxmlformats.org/drawingml/2006/main" xmlns:r="http://schemas.openxmlformats.org/officeDocument/2006/relationships" xmlns:p="http://schemas.openxmlformats.org/presentationml/2006/main">
+  <p:cSld name="Slide 15 - Wireframes">
+    <p:bg>
+      <p:bgPr>
+        <a:solidFill>
+          <a:srgbClr val="F7F5F0"/>
+        </a:solidFill>
+        <a:effectLst/>
+      </p:bgPr>
+    </p:bg>
+    <p:spTree>
+      <p:nvGrpSpPr>
+        <p:cNvPr id="1" name=""/>
+        <p:cNvGrpSpPr/>
+        <p:nvPr/>
+      </p:nvGrpSpPr>
+      <p:grpSpPr>
+        <a:xfrm>
+          <a:off x="0" y="0"/>
+          <a:ext cx="0" cy="0"/>
+          <a:chOff x="0" y="0"/>
+          <a:chExt cx="0" cy="0"/>
+        </a:xfrm>
+      </p:grpSpPr>
+      <p:sp>
+        <p:nvSpPr>
+          <p:cNvPr id="2" name="Text 0"/>
+          <p:cNvSpPr/>
+          <p:nvPr/>
+        </p:nvSpPr>
+        <p:spPr>
+          <a:xfrm>
+            <a:off x="548640" y="384048"/>
+            <a:ext cx="11094415" cy="274320"/>
+          </a:xfrm>
+          <a:prstGeom prst="rect">
+            <a:avLst/>
+          </a:prstGeom>
+          <a:noFill/>
+          <a:ln/>
+        </p:spPr>
+        <p:txBody>
+          <a:bodyPr wrap="square" lIns="0" tIns="0" rIns="0" bIns="0" rtlCol="0" anchor="ctr"/>
+          <a:lstStyle/>
+          <a:p>
+            <a:pPr marL="0" indent="0">
+              <a:buNone/>
+            </a:pPr>
+            <a:r>
+              <a:rPr lang="en-US" sz="1150" b="1" kern="0" spc="200" dirty="0">
+                <a:solidFill>
+                  <a:srgbClr val="E8501A"/>
+                </a:solidFill>
+                <a:latin typeface="Calibri" pitchFamily="34" charset="0"/>
+                <a:ea typeface="Calibri" pitchFamily="34" charset="-122"/>
+                <a:cs typeface="Calibri" pitchFamily="34" charset="-120"/>
+              </a:rPr>
+              <a:t>CONCEPTION</a:t>
+            </a:r>
+            <a:endParaRPr lang="en-US" sz="1150" dirty="0"/>
+          </a:p>
+        </p:txBody>
+      </p:sp>
+      <p:sp>
+        <p:nvSpPr>
+          <p:cNvPr id="3" name="Text 1"/>
+          <p:cNvSpPr/>
+          <p:nvPr/>
+        </p:nvSpPr>
+        <p:spPr>
+          <a:xfrm>
+            <a:off x="548640" y="640080"/>
+            <a:ext cx="11094415" cy="640080"/>
+          </a:xfrm>
+          <a:prstGeom prst="rect">
+            <a:avLst/>
+          </a:prstGeom>
+          <a:noFill/>
+          <a:ln/>
+        </p:spPr>
+        <p:txBody>
+          <a:bodyPr wrap="square" lIns="0" tIns="0" rIns="0" bIns="0" rtlCol="0" anchor="ctr"/>
+          <a:lstStyle/>
+          <a:p>
+            <a:pPr marL="0" indent="0">
+              <a:buNone/>
+            </a:pPr>
+            <a:r>
+              <a:rPr lang="en-US" sz="3000" b="1" dirty="0">
+                <a:solidFill>
+                  <a:srgbClr val="1A3A5C"/>
+                </a:solidFill>
+                <a:latin typeface="Cambria" pitchFamily="34" charset="0"/>
+                <a:ea typeface="Cambria" pitchFamily="34" charset="-122"/>
+                <a:cs typeface="Cambria" pitchFamily="34" charset="-120"/>
+              </a:rPr>
+              <a:t>Wireframes du projet</a:t>
+            </a:r>
+            <a:endParaRPr lang="en-US" sz="3000" dirty="0"/>
+          </a:p>
+        </p:txBody>
+      </p:sp>
+      <p:sp>
+        <p:nvSpPr>
+          <p:cNvPr id="6" name="Shape 3"/>
+          <p:cNvSpPr/>
+          <p:nvPr/>
+        </p:nvSpPr>
+        <p:spPr>
+          <a:xfrm>
+            <a:off x="548640" y="1417320"/>
+            <a:ext cx="5074920" cy="3931920"/>
+          </a:xfrm>
+          <a:prstGeom prst="roundRect">
+            <a:avLst>
+              <a:gd name="adj" fmla="val 2093"/>
+            </a:avLst>
+          </a:prstGeom>
+          <a:solidFill>
+            <a:srgbClr val="FFFFFF"/>
+          </a:solidFill>
+          <a:ln w="9525">
+            <a:solidFill>
+              <a:srgbClr val="D1CEC6"/>
+            </a:solidFill>
+            <a:prstDash val="solid"/>
+          </a:ln>
+          <a:effectLst>
+            <a:outerShdw blurRad="127000" dist="38100" dir="5400000" algn="bl" rotWithShape="0">
+              <a:srgbClr val="0A1622">
+                <a:alpha val="18000"/>
+              </a:srgbClr>
+            </a:outerShdw>
+          </a:effectLst>
+        </p:spPr>
+      </p:sp>
+      <p:pic>
+        <p:nvPicPr>
+          <p:cNvPr id="7" name="Image 1" descr="/home/claude/villenova-deck/images/Screenshot_2026-04-30_235619.png"/>
+          <p:cNvPicPr>
+            <a:picLocks noChangeAspect="1"/>
+          </p:cNvPicPr>
+          <p:nvPr/>
+        </p:nvPicPr>
+        <p:blipFill>
+          <a:blip r:embed="rId3"/>
+          <a:stretch>
+            <a:fillRect/>
+          </a:stretch>
+        </p:blipFill>
+        <p:spPr>
+          <a:xfrm>
+            <a:off x="1327933" y="1581912"/>
+            <a:ext cx="3516333" cy="3474720"/>
+          </a:xfrm>
+          <a:prstGeom prst="rect">
+            <a:avLst/>
+          </a:prstGeom>
+        </p:spPr>
+      </p:pic>
+      <p:sp>
+        <p:nvSpPr>
+          <p:cNvPr id="8" name="Text 4"/>
+          <p:cNvSpPr/>
+          <p:nvPr/>
+        </p:nvSpPr>
+        <p:spPr>
+          <a:xfrm>
+            <a:off x="548640" y="5440680"/>
+            <a:ext cx="5074920" cy="320040"/>
+          </a:xfrm>
+          <a:prstGeom prst="rect">
+            <a:avLst/>
+          </a:prstGeom>
+          <a:noFill/>
+          <a:ln/>
+        </p:spPr>
+        <p:txBody>
+          <a:bodyPr wrap="square" lIns="0" tIns="0" rIns="0" bIns="0" rtlCol="0" anchor="ctr"/>
+          <a:lstStyle/>
+          <a:p>
+            <a:pPr marL="0" indent="0">
+              <a:buNone/>
+            </a:pPr>
+            <a:r>
+              <a:rPr lang="en-US" sz="1400" b="1" dirty="0">
+                <a:solidFill>
+                  <a:srgbClr val="1A3A5C"/>
+                </a:solidFill>
+                <a:latin typeface="Cambria" pitchFamily="34" charset="0"/>
+                <a:ea typeface="Cambria" pitchFamily="34" charset="-122"/>
+                <a:cs typeface="Cambria" pitchFamily="34" charset="-120"/>
+              </a:rPr>
+              <a:t>Version desktop</a:t>
+            </a:r>
+            <a:endParaRPr lang="en-US" sz="1400" dirty="0"/>
+          </a:p>
+        </p:txBody>
+      </p:sp>
+      <p:sp>
+        <p:nvSpPr>
+          <p:cNvPr id="9" name="Text 5"/>
+          <p:cNvSpPr/>
+          <p:nvPr/>
+        </p:nvSpPr>
+        <p:spPr>
+          <a:xfrm>
+            <a:off x="548640" y="5742432"/>
+            <a:ext cx="5074920" cy="548640"/>
+          </a:xfrm>
+          <a:prstGeom prst="rect">
+            <a:avLst/>
+          </a:prstGeom>
+          <a:noFill/>
+          <a:ln/>
+        </p:spPr>
+        <p:txBody>
+          <a:bodyPr wrap="square" lIns="0" tIns="0" rIns="0" bIns="0" rtlCol="0" anchor="ctr"/>
+          <a:lstStyle/>
+          <a:p>
+            <a:pPr marL="0" indent="0">
+              <a:lnSpc>
+                <a:spcPct val="115000"/>
+              </a:lnSpc>
+              <a:buNone/>
+            </a:pPr>
+            <a:r>
+              <a:rPr lang="en-US" sz="1150" dirty="0">
+                <a:solidFill>
+                  <a:srgbClr val="6B7280"/>
+                </a:solidFill>
+                <a:latin typeface="Calibri" pitchFamily="34" charset="0"/>
+                <a:ea typeface="Calibri" pitchFamily="34" charset="-122"/>
+                <a:cs typeface="Calibri" pitchFamily="34" charset="-120"/>
+              </a:rPr>
+              <a:t>Structure basse-fidélité du site : hiérarchie des blocs, navigation et grille de cartes</a:t>
+            </a:r>
+            <a:endParaRPr lang="en-US" sz="1150" dirty="0"/>
+          </a:p>
+        </p:txBody>
+      </p:sp>
+      <p:sp>
+        <p:nvSpPr>
+          <p:cNvPr id="10" name="Shape 6"/>
+          <p:cNvSpPr/>
+          <p:nvPr/>
+        </p:nvSpPr>
+        <p:spPr>
+          <a:xfrm>
+            <a:off x="6537960" y="1417320"/>
+            <a:ext cx="5074920" cy="3931920"/>
+          </a:xfrm>
+          <a:prstGeom prst="roundRect">
+            <a:avLst>
+              <a:gd name="adj" fmla="val 2093"/>
+            </a:avLst>
+          </a:prstGeom>
+          <a:solidFill>
+            <a:srgbClr val="FFFFFF"/>
+          </a:solidFill>
+          <a:ln w="9525">
+            <a:solidFill>
+              <a:srgbClr val="D1CEC6"/>
+            </a:solidFill>
+            <a:prstDash val="solid"/>
+          </a:ln>
+          <a:effectLst>
+            <a:outerShdw blurRad="127000" dist="38100" dir="5400000" algn="bl" rotWithShape="0">
+              <a:srgbClr val="0A1622">
+                <a:alpha val="18000"/>
+              </a:srgbClr>
+            </a:outerShdw>
+          </a:effectLst>
+        </p:spPr>
+      </p:sp>
+      <p:pic>
+        <p:nvPicPr>
+          <p:cNvPr id="11" name="Image 2" descr="/home/claude/villenova-deck/images/Screenshot_2026-05-04_001850.png"/>
+          <p:cNvPicPr>
+            <a:picLocks noChangeAspect="1"/>
+          </p:cNvPicPr>
+          <p:nvPr/>
+        </p:nvPicPr>
+        <p:blipFill>
+          <a:blip r:embed="rId4"/>
+          <a:stretch>
+            <a:fillRect/>
+          </a:stretch>
+        </p:blipFill>
+        <p:spPr>
+          <a:xfrm>
+            <a:off x="8215180" y="1581912"/>
+            <a:ext cx="1720482" cy="3474720"/>
+          </a:xfrm>
+          <a:prstGeom prst="rect">
+            <a:avLst/>
+          </a:prstGeom>
+        </p:spPr>
+      </p:pic>
+      <p:sp>
+        <p:nvSpPr>
+          <p:cNvPr id="12" name="Text 7"/>
+          <p:cNvSpPr/>
+          <p:nvPr/>
+        </p:nvSpPr>
+        <p:spPr>
+          <a:xfrm>
+            <a:off x="6537960" y="5440680"/>
+            <a:ext cx="5074920" cy="320040"/>
+          </a:xfrm>
+          <a:prstGeom prst="rect">
+            <a:avLst/>
+          </a:prstGeom>
+          <a:noFill/>
+          <a:ln/>
+        </p:spPr>
+        <p:txBody>
+          <a:bodyPr wrap="square" lIns="0" tIns="0" rIns="0" bIns="0" rtlCol="0" anchor="ctr"/>
+          <a:lstStyle/>
+          <a:p>
+            <a:pPr marL="0" indent="0">
+              <a:buNone/>
+            </a:pPr>
+            <a:r>
+              <a:rPr lang="en-US" sz="1400" b="1" dirty="0">
+                <a:solidFill>
+                  <a:srgbClr val="1A3A5C"/>
+                </a:solidFill>
+                <a:latin typeface="Cambria" pitchFamily="34" charset="0"/>
+                <a:ea typeface="Cambria" pitchFamily="34" charset="-122"/>
+                <a:cs typeface="Cambria" pitchFamily="34" charset="-120"/>
+              </a:rPr>
+              <a:t>Version mobile</a:t>
+            </a:r>
+            <a:endParaRPr lang="en-US" sz="1400" dirty="0"/>
+          </a:p>
+        </p:txBody>
+      </p:sp>
+      <p:sp>
+        <p:nvSpPr>
+          <p:cNvPr id="13" name="Text 8"/>
+          <p:cNvSpPr/>
+          <p:nvPr/>
+        </p:nvSpPr>
+        <p:spPr>
+          <a:xfrm>
+            <a:off x="6537960" y="5742432"/>
+            <a:ext cx="5074920" cy="548640"/>
+          </a:xfrm>
+          <a:prstGeom prst="rect">
+            <a:avLst/>
+          </a:prstGeom>
+          <a:noFill/>
+          <a:ln/>
+        </p:spPr>
+        <p:txBody>
+          <a:bodyPr wrap="square" lIns="0" tIns="0" rIns="0" bIns="0" rtlCol="0" anchor="ctr"/>
+          <a:lstStyle/>
+          <a:p>
+            <a:pPr marL="0" indent="0">
+              <a:lnSpc>
+                <a:spcPct val="115000"/>
+              </a:lnSpc>
+              <a:buNone/>
+            </a:pPr>
+            <a:r>
+              <a:rPr lang="en-US" sz="1150" dirty="0">
+                <a:solidFill>
+                  <a:srgbClr val="6B7280"/>
+                </a:solidFill>
+                <a:latin typeface="Calibri" pitchFamily="34" charset="0"/>
+                <a:ea typeface="Calibri" pitchFamily="34" charset="-122"/>
+                <a:cs typeface="Calibri" pitchFamily="34" charset="-120"/>
+              </a:rPr>
+              <a:t>Adaptation responsive : recentrage du contenu, filtres en scroll horizontal, cartes empilées</a:t>
+            </a:r>
+            <a:endParaRPr lang="en-US" sz="1150" dirty="0"/>
+          </a:p>
+        </p:txBody>
+      </p:sp>
+      <p:sp>
+        <p:nvSpPr>
+          <p:cNvPr id="16" name="Text 10"/>
+          <p:cNvSpPr/>
+          <p:nvPr/>
+        </p:nvSpPr>
+        <p:spPr>
+          <a:xfrm>
+            <a:off x="11002975" y="6446520"/>
+            <a:ext cx="914400" cy="274320"/>
+          </a:xfrm>
+          <a:prstGeom prst="rect">
+            <a:avLst/>
+          </a:prstGeom>
+          <a:noFill/>
+          <a:ln/>
+        </p:spPr>
+        <p:txBody>
+          <a:bodyPr wrap="square" lIns="0" tIns="0" rIns="0" bIns="0" rtlCol="0" anchor="ctr"/>
+          <a:lstStyle/>
+          <a:p>
+            <a:pPr marL="0" indent="0" algn="r">
+              <a:buNone/>
+            </a:pPr>
+            <a:r>
+              <a:rPr lang="en-US" sz="900" dirty="0">
+                <a:solidFill>
+                  <a:srgbClr val="6B7280"/>
+                </a:solidFill>
+                <a:latin typeface="Calibri" pitchFamily="34" charset="0"/>
+                <a:ea typeface="Calibri" pitchFamily="34" charset="-122"/>
+                <a:cs typeface="Calibri" pitchFamily="34" charset="-120"/>
+              </a:rPr>
+              <a:t>7 / 17</a:t>
+            </a:r>
+            <a:endParaRPr lang="en-US" sz="900" dirty="0"/>
+          </a:p>
+        </p:txBody>
+      </p:sp>
+    </p:spTree>
+  </p:cSld>
+  <p:clrMapOvr>
+    <a:masterClrMapping/>
+  </p:clrMapOvr>
+  <mc:AlternateContent xmlns:mc="http://schemas.openxmlformats.org/markup-compatibility/2006" xmlns:p159="http://schemas.microsoft.com/office/powerpoint/2015/09/main">
+    <mc:Choice Requires="p159">
+      <p:transition xmlns:p14="http://schemas.microsoft.com/office/powerpoint/2010/main" spd="slow" p14:dur="2000">
+        <p159:morph option="byObject"/>
+      </p:transition>
+    </mc:Choice>
+    <mc:Fallback xmlns="">
+      <p:transition spd="slow">
+        <p:fade/>
+      </p:transition>
+    </mc:Fallback>
+  </mc:AlternateContent>
+</p:sld>
+</file>
+
+<file path=ppt/slides/slide16.xml><?xml version="1.0" encoding="utf-8"?>
+<p:sld xmlns:a="http://schemas.openxmlformats.org/drawingml/2006/main" xmlns:r="http://schemas.openxmlformats.org/officeDocument/2006/relationships" xmlns:p="http://schemas.openxmlformats.org/presentationml/2006/main">
+  <p:cSld name="Slide 16 - Maquette HD">
+    <p:bg>
+      <p:bgPr>
+        <a:solidFill>
+          <a:srgbClr val="F7F5F0"/>
+        </a:solidFill>
+        <a:effectLst/>
+      </p:bgPr>
+    </p:bg>
+    <p:spTree>
+      <p:nvGrpSpPr>
+        <p:cNvPr id="1" name=""/>
+        <p:cNvGrpSpPr/>
+        <p:nvPr/>
+      </p:nvGrpSpPr>
+      <p:grpSpPr>
+        <a:xfrm>
+          <a:off x="0" y="0"/>
+          <a:ext cx="0" cy="0"/>
+          <a:chOff x="0" y="0"/>
+          <a:chExt cx="0" cy="0"/>
+        </a:xfrm>
+      </p:grpSpPr>
+      <p:sp>
+        <p:nvSpPr>
+          <p:cNvPr id="2" name="Text 0"/>
+          <p:cNvSpPr/>
+          <p:nvPr/>
+        </p:nvSpPr>
+        <p:spPr>
+          <a:xfrm>
+            <a:off x="548640" y="384048"/>
+            <a:ext cx="11094415" cy="274320"/>
+          </a:xfrm>
+          <a:prstGeom prst="rect">
+            <a:avLst/>
+          </a:prstGeom>
+          <a:noFill/>
+          <a:ln/>
+        </p:spPr>
+        <p:txBody>
+          <a:bodyPr wrap="square" lIns="0" tIns="0" rIns="0" bIns="0" rtlCol="0" anchor="ctr"/>
+          <a:lstStyle/>
+          <a:p>
+            <a:pPr marL="0" indent="0">
+              <a:buNone/>
+            </a:pPr>
+            <a:r>
+              <a:rPr lang="en-US" sz="1150" b="1" kern="0" spc="200" dirty="0">
+                <a:solidFill>
+                  <a:srgbClr val="E8501A"/>
+                </a:solidFill>
+                <a:latin typeface="Calibri" pitchFamily="34" charset="0"/>
+                <a:ea typeface="Calibri" pitchFamily="34" charset="-122"/>
+                <a:cs typeface="Calibri" pitchFamily="34" charset="-120"/>
+              </a:rPr>
+              <a:t>CONCEPTION</a:t>
+            </a:r>
+            <a:endParaRPr lang="en-US" sz="1150" dirty="0"/>
+          </a:p>
+        </p:txBody>
+      </p:sp>
+      <p:sp>
+        <p:nvSpPr>
+          <p:cNvPr id="3" name="Text 1"/>
+          <p:cNvSpPr/>
+          <p:nvPr/>
+        </p:nvSpPr>
+        <p:spPr>
+          <a:xfrm>
+            <a:off x="548640" y="640080"/>
+            <a:ext cx="11094415" cy="640080"/>
+          </a:xfrm>
+          <a:prstGeom prst="rect">
+            <a:avLst/>
+          </a:prstGeom>
+          <a:noFill/>
+          <a:ln/>
+        </p:spPr>
+        <p:txBody>
+          <a:bodyPr wrap="square" lIns="0" tIns="0" rIns="0" bIns="0" rtlCol="0" anchor="ctr"/>
+          <a:lstStyle/>
+          <a:p>
+            <a:pPr marL="0" indent="0">
+              <a:buNone/>
+            </a:pPr>
+            <a:r>
+              <a:rPr lang="en-US" sz="3000" b="1" dirty="0">
+                <a:solidFill>
+                  <a:srgbClr val="1A3A5C"/>
+                </a:solidFill>
+                <a:latin typeface="Cambria" pitchFamily="34" charset="0"/>
+                <a:ea typeface="Cambria" pitchFamily="34" charset="-122"/>
+                <a:cs typeface="Cambria" pitchFamily="34" charset="-120"/>
+              </a:rPr>
+              <a:t>Maquette haute-fidélité</a:t>
+            </a:r>
+            <a:endParaRPr lang="en-US" sz="3000" dirty="0"/>
+          </a:p>
+        </p:txBody>
+      </p:sp>
+      <p:sp>
+        <p:nvSpPr>
+          <p:cNvPr id="6" name="Shape 3"/>
+          <p:cNvSpPr/>
+          <p:nvPr/>
+        </p:nvSpPr>
+        <p:spPr>
+          <a:xfrm>
+            <a:off x="548640" y="1417320"/>
+            <a:ext cx="5074920" cy="3931920"/>
+          </a:xfrm>
+          <a:prstGeom prst="roundRect">
+            <a:avLst>
+              <a:gd name="adj" fmla="val 2093"/>
+            </a:avLst>
+          </a:prstGeom>
+          <a:solidFill>
+            <a:srgbClr val="FFFFFF"/>
+          </a:solidFill>
+          <a:ln w="9525">
+            <a:solidFill>
+              <a:srgbClr val="D1CEC6"/>
+            </a:solidFill>
+            <a:prstDash val="solid"/>
+          </a:ln>
+          <a:effectLst>
+            <a:outerShdw blurRad="127000" dist="38100" dir="5400000" algn="bl" rotWithShape="0">
+              <a:srgbClr val="0A1622">
+                <a:alpha val="18000"/>
+              </a:srgbClr>
+            </a:outerShdw>
+          </a:effectLst>
+        </p:spPr>
+      </p:sp>
+      <p:pic>
+        <p:nvPicPr>
+          <p:cNvPr id="7" name="Image 1" descr="/home/claude/villenova-deck/images/Screenshot_2026-04-30_235619.png"/>
+          <p:cNvPicPr>
+            <a:picLocks noChangeAspect="1"/>
+          </p:cNvPicPr>
+          <p:nvPr/>
+        </p:nvPicPr>
+        <p:blipFill>
+          <a:blip r:embed="rId3"/>
+          <a:stretch>
+            <a:fillRect/>
+          </a:stretch>
+        </p:blipFill>
+        <p:spPr>
+          <a:xfrm>
+            <a:off x="1527682" y="1581912"/>
+            <a:ext cx="3116835" cy="3474720"/>
+          </a:xfrm>
+          <a:prstGeom prst="rect">
+            <a:avLst/>
+          </a:prstGeom>
+        </p:spPr>
+      </p:pic>
+      <p:sp>
+        <p:nvSpPr>
+          <p:cNvPr id="8" name="Text 4"/>
+          <p:cNvSpPr/>
+          <p:nvPr/>
+        </p:nvSpPr>
+        <p:spPr>
+          <a:xfrm>
+            <a:off x="548640" y="5440680"/>
+            <a:ext cx="5074920" cy="320040"/>
+          </a:xfrm>
+          <a:prstGeom prst="rect">
+            <a:avLst/>
+          </a:prstGeom>
+          <a:noFill/>
+          <a:ln/>
+        </p:spPr>
+        <p:txBody>
+          <a:bodyPr wrap="square" lIns="0" tIns="0" rIns="0" bIns="0" rtlCol="0" anchor="ctr"/>
+          <a:lstStyle/>
+          <a:p>
+            <a:pPr marL="0" indent="0">
+              <a:buNone/>
+            </a:pPr>
+            <a:r>
+              <a:rPr lang="en-US" sz="1400" b="1" dirty="0">
+                <a:solidFill>
+                  <a:srgbClr val="1A3A5C"/>
+                </a:solidFill>
+                <a:latin typeface="Cambria" pitchFamily="34" charset="0"/>
+                <a:ea typeface="Cambria" pitchFamily="34" charset="-122"/>
+                <a:cs typeface="Cambria" pitchFamily="34" charset="-120"/>
+              </a:rPr>
+              <a:t>Version desktop</a:t>
+            </a:r>
+            <a:endParaRPr lang="en-US" sz="1400" dirty="0"/>
+          </a:p>
+        </p:txBody>
+      </p:sp>
+      <p:sp>
+        <p:nvSpPr>
+          <p:cNvPr id="9" name="Text 5"/>
+          <p:cNvSpPr/>
+          <p:nvPr/>
+        </p:nvSpPr>
+        <p:spPr>
+          <a:xfrm>
+            <a:off x="548640" y="5742432"/>
+            <a:ext cx="5074920" cy="548640"/>
+          </a:xfrm>
+          <a:prstGeom prst="rect">
+            <a:avLst/>
+          </a:prstGeom>
+          <a:noFill/>
+          <a:ln/>
+        </p:spPr>
+        <p:txBody>
+          <a:bodyPr wrap="square" lIns="0" tIns="0" rIns="0" bIns="0" rtlCol="0" anchor="ctr"/>
+          <a:lstStyle/>
+          <a:p>
+            <a:pPr marL="0" indent="0">
+              <a:lnSpc>
+                <a:spcPct val="115000"/>
+              </a:lnSpc>
+              <a:buNone/>
+            </a:pPr>
+            <a:r>
+              <a:rPr lang="en-US" sz="1150" dirty="0">
+                <a:solidFill>
+                  <a:srgbClr val="6B7280"/>
+                </a:solidFill>
+                <a:latin typeface="Calibri" pitchFamily="34" charset="0"/>
+                <a:ea typeface="Calibri" pitchFamily="34" charset="-122"/>
+                <a:cs typeface="Calibri" pitchFamily="34" charset="-120"/>
+              </a:rPr>
+              <a:t>Charte graphique appliquée : navy, orange et jaune, typographies Syne et DM Sans</a:t>
+            </a:r>
+            <a:endParaRPr lang="en-US" sz="1150" dirty="0"/>
+          </a:p>
+        </p:txBody>
+      </p:sp>
+      <p:sp>
+        <p:nvSpPr>
+          <p:cNvPr id="10" name="Shape 6"/>
+          <p:cNvSpPr/>
+          <p:nvPr/>
+        </p:nvSpPr>
+        <p:spPr>
+          <a:xfrm>
+            <a:off x="6537960" y="1417320"/>
+            <a:ext cx="5074920" cy="3931920"/>
+          </a:xfrm>
+          <a:prstGeom prst="roundRect">
+            <a:avLst>
+              <a:gd name="adj" fmla="val 2093"/>
+            </a:avLst>
+          </a:prstGeom>
+          <a:solidFill>
+            <a:srgbClr val="FFFFFF"/>
+          </a:solidFill>
+          <a:ln w="9525">
+            <a:solidFill>
+              <a:srgbClr val="D1CEC6"/>
+            </a:solidFill>
+            <a:prstDash val="solid"/>
+          </a:ln>
+          <a:effectLst>
+            <a:outerShdw blurRad="127000" dist="38100" dir="5400000" algn="bl" rotWithShape="0">
+              <a:srgbClr val="0A1622">
+                <a:alpha val="18000"/>
+              </a:srgbClr>
+            </a:outerShdw>
+          </a:effectLst>
+        </p:spPr>
+      </p:sp>
+      <p:pic>
+        <p:nvPicPr>
+          <p:cNvPr id="11" name="Image 2" descr="/home/claude/villenova-deck/images/Screenshot_2026-05-04_001850.png"/>
+          <p:cNvPicPr>
+            <a:picLocks noChangeAspect="1"/>
+          </p:cNvPicPr>
+          <p:nvPr/>
+        </p:nvPicPr>
+        <p:blipFill>
+          <a:blip r:embed="rId4"/>
+          <a:stretch>
+            <a:fillRect/>
+          </a:stretch>
+        </p:blipFill>
+        <p:spPr>
+          <a:xfrm>
+            <a:off x="8719010" y="1581912"/>
+            <a:ext cx="712820" cy="3474720"/>
+          </a:xfrm>
+          <a:prstGeom prst="rect">
+            <a:avLst/>
+          </a:prstGeom>
+        </p:spPr>
+      </p:pic>
+      <p:sp>
+        <p:nvSpPr>
+          <p:cNvPr id="12" name="Text 7"/>
+          <p:cNvSpPr/>
+          <p:nvPr/>
+        </p:nvSpPr>
+        <p:spPr>
+          <a:xfrm>
+            <a:off x="6537960" y="5440680"/>
+            <a:ext cx="5074920" cy="320040"/>
+          </a:xfrm>
+          <a:prstGeom prst="rect">
+            <a:avLst/>
+          </a:prstGeom>
+          <a:noFill/>
+          <a:ln/>
+        </p:spPr>
+        <p:txBody>
+          <a:bodyPr wrap="square" lIns="0" tIns="0" rIns="0" bIns="0" rtlCol="0" anchor="ctr"/>
+          <a:lstStyle/>
+          <a:p>
+            <a:pPr marL="0" indent="0">
+              <a:buNone/>
+            </a:pPr>
+            <a:r>
+              <a:rPr lang="en-US" sz="1400" b="1" dirty="0">
+                <a:solidFill>
+                  <a:srgbClr val="1A3A5C"/>
+                </a:solidFill>
+                <a:latin typeface="Cambria" pitchFamily="34" charset="0"/>
+                <a:ea typeface="Cambria" pitchFamily="34" charset="-122"/>
+                <a:cs typeface="Cambria" pitchFamily="34" charset="-120"/>
+              </a:rPr>
+              <a:t>Version mobile</a:t>
+            </a:r>
+            <a:endParaRPr lang="en-US" sz="1400" dirty="0"/>
+          </a:p>
+        </p:txBody>
+      </p:sp>
+      <p:sp>
+        <p:nvSpPr>
+          <p:cNvPr id="13" name="Text 8"/>
+          <p:cNvSpPr/>
+          <p:nvPr/>
+        </p:nvSpPr>
+        <p:spPr>
+          <a:xfrm>
+            <a:off x="6537960" y="5742432"/>
+            <a:ext cx="5074920" cy="548640"/>
+          </a:xfrm>
+          <a:prstGeom prst="rect">
+            <a:avLst/>
+          </a:prstGeom>
+          <a:noFill/>
+          <a:ln/>
+        </p:spPr>
+        <p:txBody>
+          <a:bodyPr wrap="square" lIns="0" tIns="0" rIns="0" bIns="0" rtlCol="0" anchor="ctr"/>
+          <a:lstStyle/>
+          <a:p>
+            <a:pPr marL="0" indent="0">
+              <a:lnSpc>
+                <a:spcPct val="115000"/>
+              </a:lnSpc>
+              <a:buNone/>
+            </a:pPr>
+            <a:r>
+              <a:rPr lang="en-US" sz="1150" dirty="0">
+                <a:solidFill>
+                  <a:srgbClr val="6B7280"/>
+                </a:solidFill>
+                <a:latin typeface="Calibri" pitchFamily="34" charset="0"/>
+                <a:ea typeface="Calibri" pitchFamily="34" charset="-122"/>
+                <a:cs typeface="Calibri" pitchFamily="34" charset="-120"/>
+              </a:rPr>
+              <a:t>Mêmes composants, hiérarchie adaptée : recherche empilée, cartes pleine largeur</a:t>
+            </a:r>
+            <a:endParaRPr lang="en-US" sz="1150" dirty="0"/>
+          </a:p>
+        </p:txBody>
+      </p:sp>
+      <p:sp>
+        <p:nvSpPr>
+          <p:cNvPr id="16" name="Text 10"/>
+          <p:cNvSpPr/>
+          <p:nvPr/>
+        </p:nvSpPr>
+        <p:spPr>
+          <a:xfrm>
+            <a:off x="11002975" y="6446520"/>
+            <a:ext cx="914400" cy="274320"/>
+          </a:xfrm>
+          <a:prstGeom prst="rect">
+            <a:avLst/>
+          </a:prstGeom>
+          <a:noFill/>
+          <a:ln/>
+        </p:spPr>
+        <p:txBody>
+          <a:bodyPr wrap="square" lIns="0" tIns="0" rIns="0" bIns="0" rtlCol="0" anchor="ctr"/>
+          <a:lstStyle/>
+          <a:p>
+            <a:pPr marL="0" indent="0" algn="r">
+              <a:buNone/>
+            </a:pPr>
+            <a:r>
+              <a:rPr lang="en-US" sz="900" dirty="0">
+                <a:solidFill>
+                  <a:srgbClr val="6B7280"/>
+                </a:solidFill>
+                <a:latin typeface="Calibri" pitchFamily="34" charset="0"/>
+                <a:ea typeface="Calibri" pitchFamily="34" charset="-122"/>
+                <a:cs typeface="Calibri" pitchFamily="34" charset="-120"/>
+              </a:rPr>
+              <a:t>8 / 17</a:t>
+            </a:r>
+            <a:endParaRPr lang="en-US" sz="900" dirty="0"/>
+          </a:p>
+        </p:txBody>
+      </p:sp>
+    </p:spTree>
+  </p:cSld>
+  <p:clrMapOvr>
+    <a:masterClrMapping/>
+  </p:clrMapOvr>
+  <mc:AlternateContent xmlns:mc="http://schemas.openxmlformats.org/markup-compatibility/2006" xmlns:p159="http://schemas.microsoft.com/office/powerpoint/2015/09/main">
+    <mc:Choice Requires="p159">
+      <p:transition xmlns:p14="http://schemas.microsoft.com/office/powerpoint/2010/main" spd="slow" p14:dur="2000">
+        <p159:morph option="byObject"/>
+      </p:transition>
+    </mc:Choice>
+    <mc:Fallback xmlns="">
+      <p:transition spd="slow">
+        <p:fade/>
+      </p:transition>
+    </mc:Fallback>
+  </mc:AlternateContent>
+</p:sld>
+</file>
+
+<file path=ppt/slides/slide17.xml><?xml version="1.0" encoding="utf-8"?>
+<p:sld xmlns:a="http://schemas.openxmlformats.org/drawingml/2006/main" xmlns:r="http://schemas.openxmlformats.org/officeDocument/2006/relationships" xmlns:p="http://schemas.openxmlformats.org/presentationml/2006/main">
+  <p:cSld name="Slide 17 - Depot GitHub">
+    <p:bg>
+      <p:bgPr>
+        <a:solidFill>
+          <a:srgbClr val="F7F5F0"/>
+        </a:solidFill>
+        <a:effectLst/>
+      </p:bgPr>
+    </p:bg>
+    <p:spTree>
+      <p:nvGrpSpPr>
+        <p:cNvPr id="1" name=""/>
+        <p:cNvGrpSpPr/>
+        <p:nvPr/>
+      </p:nvGrpSpPr>
+      <p:grpSpPr>
+        <a:xfrm>
+          <a:off x="0" y="0"/>
+          <a:ext cx="0" cy="0"/>
+          <a:chOff x="0" y="0"/>
+          <a:chExt cx="0" cy="0"/>
+        </a:xfrm>
+      </p:grpSpPr>
+      <p:sp>
+        <p:nvSpPr>
+          <p:cNvPr id="2" name="Text 0"/>
+          <p:cNvSpPr/>
+          <p:nvPr/>
+        </p:nvSpPr>
+        <p:spPr>
+          <a:xfrm>
+            <a:off x="548640" y="384048"/>
+            <a:ext cx="11094415" cy="274320"/>
+          </a:xfrm>
+          <a:prstGeom prst="rect">
+            <a:avLst/>
+          </a:prstGeom>
+          <a:noFill/>
+          <a:ln/>
+        </p:spPr>
+        <p:txBody>
+          <a:bodyPr wrap="square" lIns="0" tIns="0" rIns="0" bIns="0" rtlCol="0" anchor="ctr"/>
+          <a:lstStyle/>
+          <a:p>
+            <a:pPr marL="0" indent="0">
+              <a:buNone/>
+            </a:pPr>
+            <a:r>
+              <a:rPr lang="en-US" sz="1150" b="1" kern="0" spc="200" dirty="0">
+                <a:solidFill>
+                  <a:srgbClr val="E8501A"/>
+                </a:solidFill>
+                <a:latin typeface="Calibri" pitchFamily="34" charset="0"/>
+                <a:ea typeface="Calibri" pitchFamily="34" charset="-122"/>
+                <a:cs typeface="Calibri" pitchFamily="34" charset="-120"/>
+              </a:rPr>
+              <a:t>VERSIONING</a:t>
+            </a:r>
+            <a:endParaRPr lang="en-US" sz="1150" dirty="0"/>
+          </a:p>
+        </p:txBody>
+      </p:sp>
+      <p:sp>
+        <p:nvSpPr>
+          <p:cNvPr id="3" name="Text 1"/>
+          <p:cNvSpPr/>
+          <p:nvPr/>
+        </p:nvSpPr>
+        <p:spPr>
+          <a:xfrm>
+            <a:off x="548640" y="640080"/>
+            <a:ext cx="11094415" cy="640080"/>
+          </a:xfrm>
+          <a:prstGeom prst="rect">
+            <a:avLst/>
+          </a:prstGeom>
+          <a:noFill/>
+          <a:ln/>
+        </p:spPr>
+        <p:txBody>
+          <a:bodyPr wrap="square" lIns="0" tIns="0" rIns="0" bIns="0" rtlCol="0" anchor="ctr"/>
+          <a:lstStyle/>
+          <a:p>
+            <a:pPr marL="0" indent="0">
+              <a:buNone/>
+            </a:pPr>
+            <a:r>
+              <a:rPr lang="en-US" sz="3000" b="1" dirty="0">
+                <a:solidFill>
+                  <a:srgbClr val="1A3A5C"/>
+                </a:solidFill>
+                <a:latin typeface="Cambria" pitchFamily="34" charset="0"/>
+                <a:ea typeface="Cambria" pitchFamily="34" charset="-122"/>
+                <a:cs typeface="Cambria" pitchFamily="34" charset="-120"/>
+              </a:rPr>
+              <a:t>Dépôt GitHub</a:t>
+            </a:r>
+            <a:endParaRPr lang="en-US" sz="3000" dirty="0"/>
+          </a:p>
+        </p:txBody>
+      </p:sp>
+      <p:sp>
+        <p:nvSpPr>
+          <p:cNvPr id="5" name="Shape 3"/>
+          <p:cNvSpPr/>
+          <p:nvPr/>
+        </p:nvSpPr>
+        <p:spPr>
+          <a:xfrm>
+            <a:off x="2614436" y="1600200"/>
+            <a:ext cx="6963127" cy="4699800"/>
+          </a:xfrm>
+          <a:prstGeom prst="roundRect">
+            <a:avLst>
+              <a:gd name="adj" fmla="val 1957"/>
+            </a:avLst>
+          </a:prstGeom>
+          <a:solidFill>
+            <a:srgbClr val="FFFFFF"/>
+          </a:solidFill>
+          <a:ln w="9525">
+            <a:solidFill>
+              <a:srgbClr val="D1CEC6"/>
+            </a:solidFill>
+            <a:prstDash val="solid"/>
+          </a:ln>
+          <a:effectLst>
+            <a:outerShdw blurRad="127000" dist="38100" dir="5400000" algn="bl" rotWithShape="0">
+              <a:srgbClr val="0A1622">
+                <a:alpha val="18000"/>
+              </a:srgbClr>
+            </a:outerShdw>
+          </a:effectLst>
+        </p:spPr>
+      </p:sp>
+      <p:pic>
+        <p:nvPicPr>
+          <p:cNvPr id="6" name="Image 0" descr="/home/claude/villenova-deck/images/Screenshot_2026-06-21_132705.png"/>
+          <p:cNvPicPr>
+            <a:picLocks noChangeAspect="1"/>
+          </p:cNvPicPr>
+          <p:nvPr/>
+        </p:nvPicPr>
+        <p:blipFill>
+          <a:blip r:embed="rId3"/>
+          <a:stretch>
+            <a:fillRect/>
+          </a:stretch>
+        </p:blipFill>
+        <p:spPr>
+          <a:xfrm>
+            <a:off x="2864436" y="1850200"/>
+            <a:ext cx="6463127" cy="3599800"/>
+          </a:xfrm>
+          <a:prstGeom prst="rect">
+            <a:avLst/>
+          </a:prstGeom>
+        </p:spPr>
+      </p:pic>
+      <p:sp>
+        <p:nvSpPr>
+          <p:cNvPr id="4" name="Text 2"/>
+          <p:cNvSpPr/>
+          <p:nvPr/>
+        </p:nvSpPr>
+        <p:spPr>
+          <a:xfrm>
+            <a:off x="2614436" y="5570000"/>
+            <a:ext cx="6963127" cy="480000"/>
+          </a:xfrm>
+          <a:prstGeom prst="rect">
+            <a:avLst/>
+          </a:prstGeom>
+          <a:noFill/>
+          <a:ln/>
+        </p:spPr>
+        <p:txBody>
+          <a:bodyPr wrap="square" lIns="0" tIns="0" rIns="0" bIns="0" rtlCol="0" anchor="t"/>
+          <a:lstStyle/>
+          <a:p>
+            <a:pPr marL="0" indent="0" algn="ctr">
+              <a:buNone/>
+            </a:pPr>
+            <a:r>
+              <a:rPr lang="en-US" sz="1200" dirty="0">
+                <a:solidFill>
+                  <a:srgbClr val="6B7280"/>
+                </a:solidFill>
+                <a:latin typeface="Calibri" pitchFamily="34" charset="0"/>
+                <a:ea typeface="Calibri" pitchFamily="34" charset="-122"/>
+                <a:cs typeface="Calibri" pitchFamily="34" charset="-120"/>
+              </a:rPr>
+              <a:t>Dossiers html / images / scripts / scss / styles, historique de commits et branches sur GitHub</a:t>
+            </a:r>
+            <a:endParaRPr lang="en-US" sz="1200" dirty="0"/>
+          </a:p>
+        </p:txBody>
+      </p:sp>
+      <p:sp>
+        <p:nvSpPr>
+          <p:cNvPr id="7" name="Text 4"/>
+          <p:cNvSpPr/>
+          <p:nvPr/>
+        </p:nvSpPr>
+        <p:spPr>
+          <a:xfrm>
+            <a:off x="11002975" y="6446520"/>
+            <a:ext cx="914400" cy="274320"/>
+          </a:xfrm>
+          <a:prstGeom prst="rect">
+            <a:avLst/>
+          </a:prstGeom>
+          <a:noFill/>
+          <a:ln/>
+        </p:spPr>
+        <p:txBody>
+          <a:bodyPr wrap="square" lIns="0" tIns="0" rIns="0" bIns="0" rtlCol="0" anchor="ctr"/>
+          <a:lstStyle/>
+          <a:p>
+            <a:pPr marL="0" indent="0" algn="r">
+              <a:buNone/>
+            </a:pPr>
+            <a:r>
+              <a:rPr lang="en-US" sz="900" dirty="0">
+                <a:solidFill>
+                  <a:srgbClr val="6B7280"/>
+                </a:solidFill>
+                <a:latin typeface="Calibri" pitchFamily="34" charset="0"/>
+                <a:ea typeface="Calibri" pitchFamily="34" charset="-122"/>
+                <a:cs typeface="Calibri" pitchFamily="34" charset="-120"/>
+              </a:rPr>
+              <a:t>6 / 17</a:t>
+            </a:r>
+            <a:endParaRPr lang="en-US" sz="900" dirty="0"/>
+          </a:p>
+        </p:txBody>
+      </p:sp>
+    </p:spTree>
+  </p:cSld>
+  <p:clrMapOvr>
+    <a:masterClrMapping/>
+  </p:clrMapOvr>
+  <mc:AlternateContent xmlns:mc="http://schemas.openxmlformats.org/markup-compatibility/2006" xmlns:p14="http://schemas.microsoft.com/office/powerpoint/2010/main">
+    <mc:Choice Requires="p14">
+      <p:transition spd="slow" p14:dur="3400">
+        <p14:reveal/>
       </p:transition>
     </mc:Choice>
     <mc:Fallback xmlns="">
@@ -5503,7 +6645,7 @@
                 <a:ea typeface="Calibri" pitchFamily="34" charset="-122"/>
                 <a:cs typeface="Calibri" pitchFamily="34" charset="-120"/>
               </a:rPr>
-              <a:t>Bachelor 1 </a:t>
+              <a:t xml:space="preserve">Bachelor 1 </a:t>
             </a:r>
             <a:r>
               <a:rPr lang="en-US" sz="1600" i="1" dirty="0" err="1">
@@ -5514,6 +6656,28 @@
                 <a:ea typeface="Calibri" pitchFamily="34" charset="-122"/>
                 <a:cs typeface="Calibri" pitchFamily="34" charset="-120"/>
               </a:rPr>
+              <a:t>concepteur</a:t>
+            </a:r>
+            <a:r>
+              <a:rPr lang="en-US" sz="1600" i="1" dirty="0">
+                <a:solidFill>
+                  <a:srgbClr val="6B7280"/>
+                </a:solidFill>
+                <a:latin typeface="Calibri" pitchFamily="34" charset="0"/>
+                <a:ea typeface="Calibri" pitchFamily="34" charset="-122"/>
+                <a:cs typeface="Calibri" pitchFamily="34" charset="-120"/>
+              </a:rPr>
+              <a:t xml:space="preserve"> </a:t>
+            </a:r>
+            <a:r>
+              <a:rPr lang="en-US" sz="1600" i="1" dirty="0" err="1">
+                <a:solidFill>
+                  <a:srgbClr val="6B7280"/>
+                </a:solidFill>
+                <a:latin typeface="Calibri" pitchFamily="34" charset="0"/>
+                <a:ea typeface="Calibri" pitchFamily="34" charset="-122"/>
+                <a:cs typeface="Calibri" pitchFamily="34" charset="-120"/>
+              </a:rPr>
               <a:t>developpeur</a:t>
             </a:r>
             <a:r>
@@ -5525,7 +6689,7 @@
                 <a:ea typeface="Calibri" pitchFamily="34" charset="-122"/>
                 <a:cs typeface="Calibri" pitchFamily="34" charset="-120"/>
               </a:rPr>
-              <a:t> </a:t>
+              <a:t xml:space="preserve"> </a:t>
             </a:r>
             <a:r>
               <a:rPr lang="en-US" sz="1600" i="1" dirty="0" err="1">
@@ -5648,7 +6812,7 @@
                 <a:ea typeface="Calibri" pitchFamily="34" charset="-122"/>
                 <a:cs typeface="Calibri" pitchFamily="34" charset="-120"/>
               </a:rPr>
-              <a:t> </a:t>
+              <a:t xml:space="preserve"> </a:t>
             </a:r>
             <a:r>
               <a:rPr lang="en-US" sz="1600" i="1" dirty="0" err="1">
@@ -5670,7 +6834,7 @@
                 <a:ea typeface="Calibri" pitchFamily="34" charset="-122"/>
                 <a:cs typeface="Calibri" pitchFamily="34" charset="-120"/>
               </a:rPr>
-              <a:t> tout seul (</a:t>
+              <a:t xml:space="preserve"> tout seul (</a:t>
             </a:r>
             <a:r>
               <a:rPr lang="en-US" sz="1600" i="1" dirty="0" err="1">
@@ -5804,7 +6968,7 @@
                 <a:ea typeface="Calibri" pitchFamily="34" charset="-122"/>
                 <a:cs typeface="Calibri" pitchFamily="34" charset="-120"/>
               </a:rPr>
-              <a:t> LinkedIn : </a:t>
+              <a:t xml:space="preserve"> LinkedIn : </a:t>
             </a:r>
             <a:r>
               <a:rPr lang="nn-NO" sz="1600" i="1" dirty="0">
@@ -5882,7 +7046,7 @@
                 <a:ea typeface="Calibri" pitchFamily="34" charset="-122"/>
                 <a:cs typeface="Calibri" pitchFamily="34" charset="-120"/>
               </a:rPr>
-              <a:t>2 / 14</a:t>
+              <a:t>2 / 17</a:t>
             </a:r>
             <a:endParaRPr lang="en-US" sz="900" dirty="0"/>
           </a:p>
@@ -6047,7 +7211,7 @@
                 <a:ea typeface="Calibri" pitchFamily="34" charset="-122"/>
                 <a:cs typeface="Calibri" pitchFamily="34" charset="-120"/>
               </a:rPr>
-              <a:t>Une application web qui centralise tous les évènements culturels de la </a:t>
+              <a:t xml:space="preserve">Une application web qui centralise tous les évènements culturels de la </a:t>
             </a:r>
             <a:r>
               <a:rPr lang="en-US" sz="1600" dirty="0" err="1">
@@ -6069,7 +7233,7 @@
                 <a:ea typeface="Calibri" pitchFamily="34" charset="-122"/>
                 <a:cs typeface="Calibri" pitchFamily="34" charset="-120"/>
               </a:rPr>
-              <a:t>, concerts; expositions; spectacles; ateliers; </a:t>
+              <a:t xml:space="preserve">, concerts; expositions; spectacles; ateliers; </a:t>
             </a:r>
             <a:r>
               <a:rPr lang="en-US" sz="1600" dirty="0" err="1">
@@ -6091,7 +7255,7 @@
                 <a:ea typeface="Calibri" pitchFamily="34" charset="-122"/>
                 <a:cs typeface="Calibri" pitchFamily="34" charset="-120"/>
               </a:rPr>
-              <a:t>  et les rend accessibles à tous, gratuits ou payants, en quelques clics.</a:t>
+              <a:t xml:space="preserve">  et les rend accessibles à tous, gratuits ou payants, en quelques clics.</a:t>
             </a:r>
             <a:endParaRPr lang="en-US" sz="1600" dirty="0"/>
           </a:p>
@@ -6607,7 +7771,7 @@
                 <a:ea typeface="Calibri" pitchFamily="34" charset="-122"/>
                 <a:cs typeface="Calibri" pitchFamily="34" charset="-120"/>
               </a:rPr>
-              <a:t>3 / 14</a:t>
+              <a:t>3 / 17</a:t>
             </a:r>
             <a:endParaRPr lang="en-US" sz="900" dirty="0"/>
           </a:p>
@@ -6800,7 +7964,7 @@
                 <a:ea typeface="Calibri" pitchFamily="34" charset="-122"/>
                 <a:cs typeface="Calibri" pitchFamily="34" charset="-120"/>
               </a:rPr>
-              <a:t>JS </a:t>
+              <a:t xml:space="preserve">JS </a:t>
             </a:r>
             <a:r>
               <a:rPr lang="en-US" sz="1550" dirty="0" err="1">
@@ -6926,8 +8090,8 @@
         </p:blipFill>
         <p:spPr>
           <a:xfrm>
-            <a:off x="6725507" y="1554480"/>
-            <a:ext cx="3876866" cy="4754880"/>
+            <a:off x="6725507" y="2188920"/>
+            <a:ext cx="3876866" cy="3486001"/>
           </a:xfrm>
           <a:prstGeom prst="rect">
             <a:avLst/>
@@ -6967,7 +8131,7 @@
                 <a:ea typeface="Calibri" pitchFamily="34" charset="-122"/>
                 <a:cs typeface="Calibri" pitchFamily="34" charset="-120"/>
               </a:rPr>
-              <a:t>4 / 14</a:t>
+              <a:t>4 / 17</a:t>
             </a:r>
             <a:endParaRPr lang="en-US" sz="900" dirty="0"/>
           </a:p>
@@ -7407,7 +8571,7 @@
                 <a:ea typeface="Calibri" pitchFamily="34" charset="-122"/>
                 <a:cs typeface="Calibri" pitchFamily="34" charset="-120"/>
               </a:rPr>
-              <a:t>Serveur proxy local pour contourner le CORS de </a:t>
+              <a:t xml:space="preserve">Serveur proxy local pour contourner le CORS de </a:t>
             </a:r>
             <a:r>
               <a:rPr lang="en-US" sz="1100" dirty="0" err="1">
@@ -7429,7 +8593,7 @@
                 <a:ea typeface="Calibri" pitchFamily="34" charset="-122"/>
                 <a:cs typeface="Calibri" pitchFamily="34" charset="-120"/>
               </a:rPr>
-              <a:t> (Source des données </a:t>
+              <a:t xml:space="preserve"> (Source des données </a:t>
             </a:r>
             <a:r>
               <a:rPr lang="en-US" sz="1100" dirty="0" err="1">
@@ -7451,7 +8615,7 @@
                 <a:ea typeface="Calibri" pitchFamily="34" charset="-122"/>
                 <a:cs typeface="Calibri" pitchFamily="34" charset="-120"/>
               </a:rPr>
-              <a:t> )</a:t>
+              <a:t xml:space="preserve"> )</a:t>
             </a:r>
             <a:endParaRPr lang="en-US" sz="1100" dirty="0"/>
           </a:p>
@@ -7923,7 +9087,7 @@
             </a:r>
             <a:r>
               <a:rPr lang="fr-FR" sz="1100" b="1" dirty="0"/>
-              <a:t> </a:t>
+              <a:t xml:space="preserve"> </a:t>
             </a:r>
             <a:r>
               <a:rPr lang="fr-FR" sz="1100" dirty="0"/>
@@ -7931,7 +9095,7 @@
             </a:r>
             <a:r>
               <a:rPr lang="fr-FR" sz="1100" b="1" dirty="0"/>
-              <a:t> </a:t>
+              <a:t xml:space="preserve"> </a:t>
             </a:r>
             <a:r>
               <a:rPr lang="fr-FR" sz="1100" dirty="0"/>
@@ -7943,7 +9107,7 @@
             </a:r>
             <a:r>
               <a:rPr lang="fr-FR" sz="1100" dirty="0"/>
-              <a:t> de logiciels tiers</a:t>
+              <a:t xml:space="preserve"> de logiciels tiers</a:t>
             </a:r>
             <a:endParaRPr lang="en-US" sz="1100" dirty="0"/>
           </a:p>
@@ -8141,7 +9305,7 @@
                 <a:ea typeface="Calibri" pitchFamily="34" charset="-122"/>
                 <a:cs typeface="Calibri" pitchFamily="34" charset="-120"/>
               </a:rPr>
-              <a:t>5 / 14</a:t>
+              <a:t>5 / 17</a:t>
             </a:r>
             <a:endParaRPr lang="en-US" sz="900" dirty="0"/>
           </a:p>
@@ -8347,7 +9511,7 @@
                 <a:ea typeface="Cambria" pitchFamily="34" charset="-122"/>
                 <a:cs typeface="Cambria" pitchFamily="34" charset="-120"/>
               </a:rPr>
-              <a:t>Eco Index   </a:t>
+              <a:t xml:space="preserve">Eco Index   </a:t>
             </a:r>
             <a:r>
               <a:rPr lang="en-US" sz="1150" u="sng" dirty="0">
@@ -8397,7 +9561,7 @@
                 <a:ea typeface="Calibri" pitchFamily="34" charset="-122"/>
                 <a:cs typeface="Calibri" pitchFamily="34" charset="-120"/>
               </a:rPr>
-              <a:t>Tester </a:t>
+              <a:t xml:space="preserve">Tester </a:t>
             </a:r>
             <a:r>
               <a:rPr lang="en-US" sz="1250" dirty="0" err="1">
@@ -8419,7 +9583,7 @@
                 <a:ea typeface="Calibri" pitchFamily="34" charset="-122"/>
                 <a:cs typeface="Calibri" pitchFamily="34" charset="-120"/>
               </a:rPr>
-              <a:t>-conception et </a:t>
+              <a:t xml:space="preserve">-conception et </a:t>
             </a:r>
             <a:r>
               <a:rPr lang="en-US" sz="1250" dirty="0" err="1">
@@ -8441,7 +9605,7 @@
                 <a:ea typeface="Calibri" pitchFamily="34" charset="-122"/>
                 <a:cs typeface="Calibri" pitchFamily="34" charset="-120"/>
               </a:rPr>
-              <a:t> </a:t>
+              <a:t xml:space="preserve"> </a:t>
             </a:r>
             <a:r>
               <a:rPr lang="en-US" sz="1250" dirty="0" err="1">
@@ -8463,7 +9627,7 @@
                 <a:ea typeface="Calibri" pitchFamily="34" charset="-122"/>
                 <a:cs typeface="Calibri" pitchFamily="34" charset="-120"/>
               </a:rPr>
-              <a:t> de son site</a:t>
+              <a:t xml:space="preserve"> de son site</a:t>
             </a:r>
             <a:endParaRPr lang="en-US" sz="1250" dirty="0"/>
           </a:p>
@@ -8580,7 +9744,7 @@
                 <a:ea typeface="Cambria" pitchFamily="34" charset="-122"/>
                 <a:cs typeface="Cambria" pitchFamily="34" charset="-120"/>
               </a:rPr>
-              <a:t> Green   </a:t>
+              <a:t xml:space="preserve"> Green   </a:t>
             </a:r>
             <a:r>
               <a:rPr lang="en-US" sz="1150" u="sng" dirty="0">
@@ -8674,7 +9838,7 @@
                 <a:ea typeface="Calibri" pitchFamily="34" charset="-122"/>
                 <a:cs typeface="Calibri" pitchFamily="34" charset="-120"/>
               </a:rPr>
-              <a:t> par rapport au RGESN (</a:t>
+              <a:t xml:space="preserve"> par rapport au RGESN (</a:t>
             </a:r>
             <a:r>
               <a:rPr lang="en-US" sz="1250" dirty="0" err="1">
@@ -8696,7 +9860,7 @@
                 <a:ea typeface="Calibri" pitchFamily="34" charset="-122"/>
                 <a:cs typeface="Calibri" pitchFamily="34" charset="-120"/>
               </a:rPr>
-              <a:t> general </a:t>
+              <a:t xml:space="preserve"> general </a:t>
             </a:r>
             <a:r>
               <a:rPr lang="en-US" sz="1250" dirty="0" err="1">
@@ -8718,7 +9882,7 @@
                 <a:ea typeface="Calibri" pitchFamily="34" charset="-122"/>
                 <a:cs typeface="Calibri" pitchFamily="34" charset="-120"/>
               </a:rPr>
-              <a:t>-conception de services </a:t>
+              <a:t xml:space="preserve">-conception de services </a:t>
             </a:r>
             <a:r>
               <a:rPr lang="en-US" sz="1250" dirty="0" err="1">
@@ -8846,7 +10010,7 @@
                 <a:ea typeface="Cambria" pitchFamily="34" charset="-122"/>
                 <a:cs typeface="Cambria" pitchFamily="34" charset="-120"/>
               </a:rPr>
-              <a:t>W3Schools — TypeScript   </a:t>
+              <a:t xml:space="preserve">W3Schools — TypeScript   </a:t>
             </a:r>
             <a:r>
               <a:rPr lang="en-US" sz="1150" u="sng" dirty="0">
@@ -9009,7 +10173,7 @@
                 <a:ea typeface="Cambria" pitchFamily="34" charset="-122"/>
                 <a:cs typeface="Cambria" pitchFamily="34" charset="-120"/>
               </a:rPr>
-              <a:t>WebAIM — Contrast Checker   </a:t>
+              <a:t xml:space="preserve">WebAIM — Contrast Checker   </a:t>
             </a:r>
             <a:r>
               <a:rPr lang="en-US" sz="1150" u="sng" dirty="0">
@@ -9172,7 +10336,7 @@
                 <a:ea typeface="Cambria" pitchFamily="34" charset="-122"/>
                 <a:cs typeface="Cambria" pitchFamily="34" charset="-120"/>
               </a:rPr>
-              <a:t>MDN — Fetch API   </a:t>
+              <a:t xml:space="preserve">MDN — Fetch API   </a:t>
             </a:r>
             <a:r>
               <a:rPr lang="en-US" sz="1150" u="sng" dirty="0">
@@ -9268,7 +10432,7 @@
                 <a:ea typeface="Calibri" pitchFamily="34" charset="-122"/>
                 <a:cs typeface="Calibri" pitchFamily="34" charset="-120"/>
               </a:rPr>
-              <a:t>6 / 14</a:t>
+              <a:t>9 / 17</a:t>
             </a:r>
             <a:endParaRPr lang="en-US" sz="900" dirty="0"/>
           </a:p>
@@ -9600,7 +10764,7 @@
                 <a:ea typeface="Courier New" pitchFamily="34" charset="-122"/>
                 <a:cs typeface="Courier New" pitchFamily="34" charset="-120"/>
               </a:rPr>
-              <a:t>  const url =</a:t>
+              <a:t xml:space="preserve">  const url =</a:t>
             </a:r>
             <a:endParaRPr lang="en-US" sz="1250" dirty="0"/>
           </a:p>
@@ -9620,7 +10784,7 @@
                 <a:ea typeface="Courier New" pitchFamily="34" charset="-122"/>
                 <a:cs typeface="Courier New" pitchFamily="34" charset="-120"/>
               </a:rPr>
-              <a:t>    `https://api.openagenda.com/v2/agendas/</a:t>
+              <a:t xml:space="preserve">    `https://api.openagenda.com/v2/agendas/</a:t>
             </a:r>
             <a:endParaRPr lang="en-US" sz="1250" dirty="0"/>
           </a:p>
@@ -9640,7 +10804,7 @@
                 <a:ea typeface="Courier New" pitchFamily="34" charset="-122"/>
                 <a:cs typeface="Courier New" pitchFamily="34" charset="-120"/>
               </a:rPr>
-              <a:t>      ${AGENDA_ID}/events?key=${API_KEY}</a:t>
+              <a:t xml:space="preserve">      ${AGENDA_ID}/events?key=${API_KEY}</a:t>
             </a:r>
             <a:endParaRPr lang="en-US" sz="1250" dirty="0"/>
           </a:p>
@@ -9660,7 +10824,7 @@
                 <a:ea typeface="Courier New" pitchFamily="34" charset="-122"/>
                 <a:cs typeface="Courier New" pitchFamily="34" charset="-120"/>
               </a:rPr>
-              <a:t>      &amp;limit=${LIMIT}&amp;offset=${off}&amp;detailed=1`;</a:t>
+              <a:t xml:space="preserve">      &amp;limit=${LIMIT}&amp;offset=${off}&amp;detailed=1`;</a:t>
             </a:r>
             <a:endParaRPr lang="en-US" sz="1250" dirty="0"/>
           </a:p>
@@ -9689,7 +10853,7 @@
                 <a:ea typeface="Courier New" pitchFamily="34" charset="-122"/>
                 <a:cs typeface="Courier New" pitchFamily="34" charset="-120"/>
               </a:rPr>
-              <a:t>  const res  = await fetch(url);</a:t>
+              <a:t xml:space="preserve">  const res  = await fetch(url);</a:t>
             </a:r>
             <a:endParaRPr lang="en-US" sz="1250" dirty="0"/>
           </a:p>
@@ -9709,7 +10873,7 @@
                 <a:ea typeface="Courier New" pitchFamily="34" charset="-122"/>
                 <a:cs typeface="Courier New" pitchFamily="34" charset="-120"/>
               </a:rPr>
-              <a:t>  const data = await res.json();</a:t>
+              <a:t xml:space="preserve">  const data = await res.json();</a:t>
             </a:r>
             <a:endParaRPr lang="en-US" sz="1250" dirty="0"/>
           </a:p>
@@ -9729,7 +10893,7 @@
                 <a:ea typeface="Courier New" pitchFamily="34" charset="-122"/>
                 <a:cs typeface="Courier New" pitchFamily="34" charset="-120"/>
               </a:rPr>
-              <a:t>  total = data.total || 0;</a:t>
+              <a:t xml:space="preserve">  total = data.total || 0;</a:t>
             </a:r>
             <a:endParaRPr lang="en-US" sz="1250" dirty="0"/>
           </a:p>
@@ -9758,7 +10922,7 @@
                 <a:ea typeface="Courier New" pitchFamily="34" charset="-122"/>
                 <a:cs typeface="Courier New" pitchFamily="34" charset="-120"/>
               </a:rPr>
-              <a:t>  (data.events || []).forEach(ev =&gt;</a:t>
+              <a:t xml:space="preserve">  (data.events || []).forEach(ev =&gt;</a:t>
             </a:r>
             <a:endParaRPr lang="en-US" sz="1250" dirty="0"/>
           </a:p>
@@ -9778,7 +10942,7 @@
                 <a:ea typeface="Courier New" pitchFamily="34" charset="-122"/>
                 <a:cs typeface="Courier New" pitchFamily="34" charset="-120"/>
               </a:rPr>
-              <a:t>    grid.appendChild(createCard(ev))</a:t>
+              <a:t xml:space="preserve">    grid.appendChild(createCard(ev))</a:t>
             </a:r>
             <a:endParaRPr lang="en-US" sz="1250" dirty="0"/>
           </a:p>
@@ -9798,7 +10962,7 @@
                 <a:ea typeface="Courier New" pitchFamily="34" charset="-122"/>
                 <a:cs typeface="Courier New" pitchFamily="34" charset="-120"/>
               </a:rPr>
-              <a:t>  );</a:t>
+              <a:t xml:space="preserve">  );</a:t>
             </a:r>
             <a:endParaRPr lang="en-US" sz="1250" dirty="0"/>
           </a:p>
@@ -9857,7 +11021,7 @@
                 <a:ea typeface="Calibri" pitchFamily="34" charset="-122"/>
                 <a:cs typeface="Calibri" pitchFamily="34" charset="-120"/>
               </a:rPr>
-              <a:t>7 / 14</a:t>
+              <a:t>10 / 17</a:t>
             </a:r>
             <a:endParaRPr lang="en-US" sz="900" dirty="0"/>
           </a:p>
@@ -10189,7 +11353,7 @@
                 <a:ea typeface="Courier New" pitchFamily="34" charset="-122"/>
                 <a:cs typeface="Courier New" pitchFamily="34" charset="-120"/>
               </a:rPr>
-              <a:t>  href="https://fonts.googleapis.com"&gt;</a:t>
+              <a:t xml:space="preserve">  href="https://fonts.googleapis.com"&gt;</a:t>
             </a:r>
             <a:endParaRPr lang="en-US" sz="1250" dirty="0"/>
           </a:p>
@@ -10229,7 +11393,7 @@
                 <a:ea typeface="Courier New" pitchFamily="34" charset="-122"/>
                 <a:cs typeface="Courier New" pitchFamily="34" charset="-120"/>
               </a:rPr>
-              <a:t>  href="https://fonts.gstatic.com" crossorigin&gt;</a:t>
+              <a:t xml:space="preserve">  href="https://fonts.gstatic.com" crossorigin&gt;</a:t>
             </a:r>
             <a:endParaRPr lang="en-US" sz="1250" dirty="0"/>
           </a:p>
@@ -10269,7 +11433,7 @@
                 <a:ea typeface="Courier New" pitchFamily="34" charset="-122"/>
                 <a:cs typeface="Courier New" pitchFamily="34" charset="-120"/>
               </a:rPr>
-              <a:t>  .com/css2?family=Syne:wght@700;800&amp;family=</a:t>
+              <a:t xml:space="preserve">  .com/css2?family=Syne:wght@700;800&amp;family=</a:t>
             </a:r>
             <a:endParaRPr lang="en-US" sz="1250" dirty="0"/>
           </a:p>
@@ -10289,7 +11453,7 @@
                 <a:ea typeface="Courier New" pitchFamily="34" charset="-122"/>
                 <a:cs typeface="Courier New" pitchFamily="34" charset="-120"/>
               </a:rPr>
-              <a:t>  DM+Sans:wght@400;500&amp;display=swap"&gt;</a:t>
+              <a:t xml:space="preserve">  DM+Sans:wght@400;500&amp;display=swap"&gt;</a:t>
             </a:r>
             <a:endParaRPr lang="en-US" sz="1250" dirty="0"/>
           </a:p>
@@ -10329,7 +11493,7 @@
                 <a:ea typeface="Courier New" pitchFamily="34" charset="-122"/>
                 <a:cs typeface="Courier New" pitchFamily="34" charset="-120"/>
               </a:rPr>
-              <a:t>  href="../images/VilleNova.webp"&gt;</a:t>
+              <a:t xml:space="preserve">  href="../images/VilleNova.webp"&gt;</a:t>
             </a:r>
             <a:endParaRPr lang="en-US" sz="1250" dirty="0"/>
           </a:p>
@@ -10388,7 +11552,7 @@
                 <a:ea typeface="Calibri" pitchFamily="34" charset="-122"/>
                 <a:cs typeface="Calibri" pitchFamily="34" charset="-120"/>
               </a:rPr>
-              <a:t>8 / 14</a:t>
+              <a:t>11 / 17</a:t>
             </a:r>
             <a:endParaRPr lang="en-US" sz="900" dirty="0"/>
           </a:p>
@@ -10779,7 +11943,7 @@
                 <a:ea typeface="Courier New" pitchFamily="34" charset="-122"/>
                 <a:cs typeface="Courier New" pitchFamily="34" charset="-120"/>
               </a:rPr>
-              <a:t>  background: $bg;</a:t>
+              <a:t xml:space="preserve">  background: $bg;</a:t>
             </a:r>
             <a:endParaRPr lang="en-US" sz="1300" dirty="0"/>
           </a:p>
@@ -10799,7 +11963,7 @@
                 <a:ea typeface="Courier New" pitchFamily="34" charset="-122"/>
                 <a:cs typeface="Courier New" pitchFamily="34" charset="-120"/>
               </a:rPr>
-              <a:t>  border-radius: 5px;</a:t>
+              <a:t xml:space="preserve">  border-radius: 5px;</a:t>
             </a:r>
             <a:endParaRPr lang="en-US" sz="1300" dirty="0"/>
           </a:p>
@@ -10819,7 +11983,7 @@
                 <a:ea typeface="Courier New" pitchFamily="34" charset="-122"/>
                 <a:cs typeface="Courier New" pitchFamily="34" charset="-120"/>
               </a:rPr>
-              <a:t>  &amp;:hover {</a:t>
+              <a:t xml:space="preserve">  &amp;:hover {</a:t>
             </a:r>
             <a:endParaRPr lang="en-US" sz="1300" dirty="0"/>
           </a:p>
@@ -10839,7 +12003,7 @@
                 <a:ea typeface="Courier New" pitchFamily="34" charset="-122"/>
                 <a:cs typeface="Courier New" pitchFamily="34" charset="-120"/>
               </a:rPr>
-              <a:t>    background: darken($bg, 8%);</a:t>
+              <a:t xml:space="preserve">    background: darken($bg, 8%);</a:t>
             </a:r>
             <a:endParaRPr lang="en-US" sz="1300" dirty="0"/>
           </a:p>
@@ -10859,7 +12023,7 @@
                 <a:ea typeface="Courier New" pitchFamily="34" charset="-122"/>
                 <a:cs typeface="Courier New" pitchFamily="34" charset="-120"/>
               </a:rPr>
-              <a:t>  }</a:t>
+              <a:t xml:space="preserve">  }</a:t>
             </a:r>
             <a:endParaRPr lang="en-US" sz="1300" dirty="0"/>
           </a:p>
@@ -11009,7 +12173,7 @@
                 <a:ea typeface="Courier New" pitchFamily="34" charset="-122"/>
                 <a:cs typeface="Courier New" pitchFamily="34" charset="-120"/>
               </a:rPr>
-              <a:t>  border-radius: 5px; }</a:t>
+              <a:t xml:space="preserve">  border-radius: 5px; }</a:t>
             </a:r>
             <a:endParaRPr lang="en-US" sz="1300" dirty="0"/>
           </a:p>
@@ -11049,7 +12213,7 @@
                 <a:ea typeface="Courier New" pitchFamily="34" charset="-122"/>
                 <a:cs typeface="Courier New" pitchFamily="34" charset="-120"/>
               </a:rPr>
-              <a:t>  background: #15314D; }</a:t>
+              <a:t xml:space="preserve">  background: #15314D; }</a:t>
             </a:r>
             <a:endParaRPr lang="en-US" sz="1300" dirty="0"/>
           </a:p>
@@ -11088,7 +12252,7 @@
                 <a:ea typeface="Calibri" pitchFamily="34" charset="-122"/>
                 <a:cs typeface="Calibri" pitchFamily="34" charset="-120"/>
               </a:rPr>
-              <a:t>9 / 14</a:t>
+              <a:t>12 / 17</a:t>
             </a:r>
             <a:endParaRPr lang="en-US" sz="900" dirty="0"/>
           </a:p>

</xml_diff>